<commit_message>
AGENTS.md 추가, song-11 pptx 업데이트
- AGENTS.md: 프로젝트 지침 문서 추가 (CLAUDE.md와 동일 내용)
- song-11 song.pptx: Aa/Ab/B 키 구조에 맞게 재생성

Co-Authored-By: Claude Sonnet 4.6 <noreply@anthropic.com>
</commit_message>
<xml_diff>
--- a/songs/song-11/song.pptx
+++ b/songs/song-11/song.pptx
@@ -5,11 +5,10 @@
     <p:sldMasterId id="2147483695" r:id="rId1"/>
   </p:sldMasterIdLst>
   <p:sldIdLst>
-    <p:sldId id="256" r:id="rId56"/>
-    <p:sldId id="257" r:id="rId57"/>
-    <p:sldId id="258" r:id="rId58"/>
-    <p:sldId id="259" r:id="rId59"/>
-    <p:sldId id="260" r:id="rId60"/>
+    <p:sldId id="256" r:id="rId2"/>
+    <p:sldId id="257" r:id="rId3"/>
+    <p:sldId id="261" r:id="rId4"/>
+    <p:sldId id="258" r:id="rId5"/>
   </p:sldIdLst>
   <p:sldSz cx="12192000" cy="6858000"/>
   <p:notesSz cx="6858000" cy="9144000"/>
@@ -268,7 +267,7 @@
               <a:pPr lvl="0">
                 <a:defRPr/>
               </a:pPr>
-              <a:t>2026. 6. 19.</a:t>
+              <a:t>2026. 8. 2.</a:t>
             </a:fld>
             <a:endParaRPr lang="ko-KR" altLang="en-US"/>
           </a:p>
@@ -460,7 +459,7 @@
               <a:pPr lvl="0">
                 <a:defRPr/>
               </a:pPr>
-              <a:t>2026. 6. 19.</a:t>
+              <a:t>2026. 8. 2.</a:t>
             </a:fld>
             <a:endParaRPr lang="ko-KR" altLang="en-US"/>
           </a:p>
@@ -662,7 +661,7 @@
               <a:pPr lvl="0">
                 <a:defRPr/>
               </a:pPr>
-              <a:t>2026. 6. 19.</a:t>
+              <a:t>2026. 8. 2.</a:t>
             </a:fld>
             <a:endParaRPr lang="ko-KR" altLang="en-US"/>
           </a:p>
@@ -862,7 +861,7 @@
               <a:pPr lvl="0">
                 <a:defRPr/>
               </a:pPr>
-              <a:t>2026. 6. 19.</a:t>
+              <a:t>2026. 8. 2.</a:t>
             </a:fld>
             <a:endParaRPr lang="ko-KR" altLang="en-US"/>
           </a:p>
@@ -1123,7 +1122,7 @@
               <a:pPr lvl="0">
                 <a:defRPr/>
               </a:pPr>
-              <a:t>2026. 6. 19.</a:t>
+              <a:t>2026. 8. 2.</a:t>
             </a:fld>
             <a:endParaRPr lang="ko-KR" altLang="en-US"/>
           </a:p>
@@ -1386,7 +1385,7 @@
               <a:pPr lvl="0">
                 <a:defRPr/>
               </a:pPr>
-              <a:t>2026. 6. 19.</a:t>
+              <a:t>2026. 8. 2.</a:t>
             </a:fld>
             <a:endParaRPr lang="ko-KR" altLang="en-US"/>
           </a:p>
@@ -1788,7 +1787,7 @@
               <a:pPr lvl="0">
                 <a:defRPr/>
               </a:pPr>
-              <a:t>2026. 6. 19.</a:t>
+              <a:t>2026. 8. 2.</a:t>
             </a:fld>
             <a:endParaRPr lang="ko-KR" altLang="en-US"/>
           </a:p>
@@ -1919,7 +1918,7 @@
               <a:pPr lvl="0">
                 <a:defRPr/>
               </a:pPr>
-              <a:t>2026. 6. 19.</a:t>
+              <a:t>2026. 8. 2.</a:t>
             </a:fld>
             <a:endParaRPr lang="ko-KR" altLang="en-US"/>
           </a:p>
@@ -2025,7 +2024,7 @@
               <a:pPr lvl="0">
                 <a:defRPr/>
               </a:pPr>
-              <a:t>2026. 6. 19.</a:t>
+              <a:t>2026. 8. 2.</a:t>
             </a:fld>
             <a:endParaRPr lang="ko-KR" altLang="en-US"/>
           </a:p>
@@ -2326,7 +2325,7 @@
               <a:pPr lvl="0">
                 <a:defRPr/>
               </a:pPr>
-              <a:t>2026. 6. 19.</a:t>
+              <a:t>2026. 8. 2.</a:t>
             </a:fld>
             <a:endParaRPr lang="ko-KR" altLang="en-US"/>
           </a:p>
@@ -2597,7 +2596,7 @@
               <a:pPr lvl="0">
                 <a:defRPr/>
               </a:pPr>
-              <a:t>2026. 6. 19.</a:t>
+              <a:t>2026. 8. 2.</a:t>
             </a:fld>
             <a:endParaRPr lang="ko-KR" altLang="en-US"/>
           </a:p>
@@ -2835,7 +2834,7 @@
               <a:pPr lvl="0">
                 <a:defRPr/>
               </a:pPr>
-              <a:t>2026. 6. 19.</a:t>
+              <a:t>2026. 8. 2.</a:t>
             </a:fld>
             <a:endParaRPr lang="ko-KR" altLang="en-US"/>
           </a:p>
@@ -3367,6 +3366,21 @@
               <a:defRPr/>
             </a:pPr>
             <a:r>
+              <a:rPr lang="en-US" altLang="ko-KR" sz="7200" b="1" spc="-300" dirty="0">
+                <a:ln w="9525">
+                  <a:solidFill>
+                    <a:prstClr val="black"/>
+                  </a:solidFill>
+                </a:ln>
+                <a:solidFill>
+                  <a:srgbClr val="FFFFFF"/>
+                </a:solidFill>
+                <a:latin typeface="휴먼모음T" panose="02030504000101010101" pitchFamily="18" charset="-127"/>
+                <a:ea typeface="휴먼모음T" panose="02030504000101010101" pitchFamily="18" charset="-127"/>
+              </a:rPr>
+              <a:t>Aa </a:t>
+            </a:r>
+            <a:r>
               <a:rPr lang="ko-KR" altLang="en-US" sz="7200" b="1" spc="-300" dirty="0">
                 <a:ln w="9525">
                   <a:solidFill>
@@ -3379,8 +3393,20 @@
                 <a:latin typeface="휴먼모음T" panose="02030504000101010101" pitchFamily="18" charset="-127"/>
                 <a:ea typeface="휴먼모음T" panose="02030504000101010101" pitchFamily="18" charset="-127"/>
               </a:rPr>
-              <a:t>나 무엇과도 주님을 바꾸지 않으리</a:t>
-            </a:r>
+              <a:t>나 무엇과도 주님을</a:t>
+            </a:r>
+            <a:endParaRPr lang="en-US" altLang="ko-KR" sz="7200" b="1" spc="-300" dirty="0">
+              <a:ln w="9525">
+                <a:solidFill>
+                  <a:prstClr val="black"/>
+                </a:solidFill>
+              </a:ln>
+              <a:solidFill>
+                <a:srgbClr val="FFFFFF"/>
+              </a:solidFill>
+              <a:latin typeface="휴먼모음T" panose="02030504000101010101" pitchFamily="18" charset="-127"/>
+              <a:ea typeface="휴먼모음T" panose="02030504000101010101" pitchFamily="18" charset="-127"/>
+            </a:endParaRPr>
           </a:p>
           <a:p>
             <a:pPr marL="0" marR="0" lvl="0" indent="0" algn="ctr" defTabSz="914400" rtl="0" eaLnBrk="1" fontAlgn="auto" latinLnBrk="1" hangingPunct="1">
@@ -3413,7 +3439,7 @@
                 <a:latin typeface="휴먼모음T" panose="02030504000101010101" pitchFamily="18" charset="-127"/>
                 <a:ea typeface="휴먼모음T" panose="02030504000101010101" pitchFamily="18" charset="-127"/>
               </a:rPr>
-              <a:t>다른 어떤 은혜 구하지 않으리</a:t>
+              <a:t>바꾸지 않으리</a:t>
             </a:r>
           </a:p>
           <a:p>
@@ -3447,8 +3473,20 @@
                 <a:latin typeface="휴먼모음T" panose="02030504000101010101" pitchFamily="18" charset="-127"/>
                 <a:ea typeface="휴먼모음T" panose="02030504000101010101" pitchFamily="18" charset="-127"/>
               </a:rPr>
-              <a:t>오직 주님만이 내 삶의 도움이시니</a:t>
-            </a:r>
+              <a:t>다른 어떤 은혜</a:t>
+            </a:r>
+            <a:endParaRPr lang="en-US" altLang="ko-KR" sz="7200" b="1" spc="-300" dirty="0">
+              <a:ln w="9525">
+                <a:solidFill>
+                  <a:prstClr val="black"/>
+                </a:solidFill>
+              </a:ln>
+              <a:solidFill>
+                <a:srgbClr val="FFFFFF"/>
+              </a:solidFill>
+              <a:latin typeface="휴먼모음T" panose="02030504000101010101" pitchFamily="18" charset="-127"/>
+              <a:ea typeface="휴먼모음T" panose="02030504000101010101" pitchFamily="18" charset="-127"/>
+            </a:endParaRPr>
           </a:p>
           <a:p>
             <a:pPr marL="0" marR="0" lvl="0" indent="0" algn="ctr" defTabSz="914400" rtl="0" eaLnBrk="1" fontAlgn="auto" latinLnBrk="1" hangingPunct="1">
@@ -3481,7 +3519,7 @@
                 <a:latin typeface="휴먼모음T" panose="02030504000101010101" pitchFamily="18" charset="-127"/>
                 <a:ea typeface="휴먼모음T" panose="02030504000101010101" pitchFamily="18" charset="-127"/>
               </a:rPr>
-              <a:t>주의 얼굴 보기 원합니다 X2</a:t>
+              <a:t>구하지 않으리</a:t>
             </a:r>
           </a:p>
         </p:txBody>
@@ -3551,6 +3589,21 @@
               <a:defRPr/>
             </a:pPr>
             <a:r>
+              <a:rPr lang="en-US" altLang="ko-KR" sz="7200" b="1" spc="-300" dirty="0">
+                <a:ln w="9525">
+                  <a:solidFill>
+                    <a:prstClr val="black"/>
+                  </a:solidFill>
+                </a:ln>
+                <a:solidFill>
+                  <a:srgbClr val="FFFFFF"/>
+                </a:solidFill>
+                <a:latin typeface="휴먼모음T" panose="02030504000101010101" pitchFamily="18" charset="-127"/>
+                <a:ea typeface="휴먼모음T" panose="02030504000101010101" pitchFamily="18" charset="-127"/>
+              </a:rPr>
+              <a:t>Ab </a:t>
+            </a:r>
+            <a:r>
               <a:rPr lang="ko-KR" altLang="en-US" sz="7200" b="1" spc="-300" dirty="0">
                 <a:ln w="9525">
                   <a:solidFill>
@@ -3563,8 +3616,20 @@
                 <a:latin typeface="휴먼모음T" panose="02030504000101010101" pitchFamily="18" charset="-127"/>
                 <a:ea typeface="휴먼모음T" panose="02030504000101010101" pitchFamily="18" charset="-127"/>
               </a:rPr>
-              <a:t>주님 사랑해요 </a:t>
-            </a:r>
+              <a:t>오직 주님만이 내 삶의</a:t>
+            </a:r>
+            <a:endParaRPr lang="en-US" altLang="ko-KR" sz="7200" b="1" spc="-300" dirty="0">
+              <a:ln w="9525">
+                <a:solidFill>
+                  <a:prstClr val="black"/>
+                </a:solidFill>
+              </a:ln>
+              <a:solidFill>
+                <a:srgbClr val="FFFFFF"/>
+              </a:solidFill>
+              <a:latin typeface="휴먼모음T" panose="02030504000101010101" pitchFamily="18" charset="-127"/>
+              <a:ea typeface="휴먼모음T" panose="02030504000101010101" pitchFamily="18" charset="-127"/>
+            </a:endParaRPr>
           </a:p>
           <a:p>
             <a:pPr marL="0" marR="0" lvl="0" indent="0" algn="ctr" defTabSz="914400" rtl="0" eaLnBrk="1" fontAlgn="auto" latinLnBrk="1" hangingPunct="1">
@@ -3597,7 +3662,7 @@
                 <a:latin typeface="휴먼모음T" panose="02030504000101010101" pitchFamily="18" charset="-127"/>
                 <a:ea typeface="휴먼모음T" panose="02030504000101010101" pitchFamily="18" charset="-127"/>
               </a:rPr>
-              <a:t>온 맘과 정성 다해</a:t>
+              <a:t>도움이시니</a:t>
             </a:r>
           </a:p>
           <a:p>
@@ -3631,8 +3696,20 @@
                 <a:latin typeface="휴먼모음T" panose="02030504000101010101" pitchFamily="18" charset="-127"/>
                 <a:ea typeface="휴먼모음T" panose="02030504000101010101" pitchFamily="18" charset="-127"/>
               </a:rPr>
-              <a:t>하나님의 신실한</a:t>
-            </a:r>
+              <a:t>주의 얼굴</a:t>
+            </a:r>
+            <a:endParaRPr lang="en-US" altLang="ko-KR" sz="7200" b="1" spc="-300" dirty="0">
+              <a:ln w="9525">
+                <a:solidFill>
+                  <a:prstClr val="black"/>
+                </a:solidFill>
+              </a:ln>
+              <a:solidFill>
+                <a:srgbClr val="FFFFFF"/>
+              </a:solidFill>
+              <a:latin typeface="휴먼모음T" panose="02030504000101010101" pitchFamily="18" charset="-127"/>
+              <a:ea typeface="휴먼모음T" panose="02030504000101010101" pitchFamily="18" charset="-127"/>
+            </a:endParaRPr>
           </a:p>
           <a:p>
             <a:pPr marL="0" marR="0" lvl="0" indent="0" algn="ctr" defTabSz="914400" rtl="0" eaLnBrk="1" fontAlgn="auto" latinLnBrk="1" hangingPunct="1">
@@ -3665,12 +3742,17 @@
                 <a:latin typeface="휴먼모음T" panose="02030504000101010101" pitchFamily="18" charset="-127"/>
                 <a:ea typeface="휴먼모음T" panose="02030504000101010101" pitchFamily="18" charset="-127"/>
               </a:rPr>
-              <a:t>친구 되기 원합니다</a:t>
+              <a:t>보기 원합니다</a:t>
             </a:r>
           </a:p>
         </p:txBody>
       </p:sp>
     </p:spTree>
+    <p:extLst>
+      <p:ext uri="{BB962C8B-B14F-4D97-AF65-F5344CB8AC3E}">
+        <p14:creationId xmlns:p14="http://schemas.microsoft.com/office/powerpoint/2010/main" val="2059709230"/>
+      </p:ext>
+    </p:extLst>
   </p:cSld>
   <p:clrMapOvr>
     <a:masterClrMapping/>
@@ -3735,6 +3817,21 @@
               <a:defRPr/>
             </a:pPr>
             <a:r>
+              <a:rPr lang="en-US" altLang="ko-KR" sz="7200" b="1" spc="-300" dirty="0">
+                <a:ln w="9525">
+                  <a:solidFill>
+                    <a:prstClr val="black"/>
+                  </a:solidFill>
+                </a:ln>
+                <a:solidFill>
+                  <a:srgbClr val="FFFFFF"/>
+                </a:solidFill>
+                <a:latin typeface="휴먼모음T" panose="02030504000101010101" pitchFamily="18" charset="-127"/>
+                <a:ea typeface="휴먼모음T" panose="02030504000101010101" pitchFamily="18" charset="-127"/>
+              </a:rPr>
+              <a:t>B </a:t>
+            </a:r>
+            <a:r>
               <a:rPr lang="ko-KR" altLang="en-US" sz="7200" b="1" spc="-300" dirty="0">
                 <a:ln w="9525">
                   <a:solidFill>
@@ -3747,7 +3844,7 @@
                 <a:latin typeface="휴먼모음T" panose="02030504000101010101" pitchFamily="18" charset="-127"/>
                 <a:ea typeface="휴먼모음T" panose="02030504000101010101" pitchFamily="18" charset="-127"/>
               </a:rPr>
-              <a:t>나 무엇과도 주님을 바꾸지 않으리</a:t>
+              <a:t>주님 사랑해요 </a:t>
             </a:r>
           </a:p>
           <a:p>
@@ -3781,7 +3878,7 @@
                 <a:latin typeface="휴먼모음T" panose="02030504000101010101" pitchFamily="18" charset="-127"/>
                 <a:ea typeface="휴먼모음T" panose="02030504000101010101" pitchFamily="18" charset="-127"/>
               </a:rPr>
-              <a:t>다른 어떤 은혜 구하지 않으리</a:t>
+              <a:t>온 맘과 정성 다해</a:t>
             </a:r>
           </a:p>
           <a:p>
@@ -3815,7 +3912,7 @@
                 <a:latin typeface="휴먼모음T" panose="02030504000101010101" pitchFamily="18" charset="-127"/>
                 <a:ea typeface="휴먼모음T" panose="02030504000101010101" pitchFamily="18" charset="-127"/>
               </a:rPr>
-              <a:t>오직 주님만이 내 삶의 도움이시니</a:t>
+              <a:t>하나님의 신실한</a:t>
             </a:r>
           </a:p>
           <a:p>
@@ -3849,191 +3946,7 @@
                 <a:latin typeface="휴먼모음T" panose="02030504000101010101" pitchFamily="18" charset="-127"/>
                 <a:ea typeface="휴먼모음T" panose="02030504000101010101" pitchFamily="18" charset="-127"/>
               </a:rPr>
-              <a:t>주의 얼굴 보기 원합니다</a:t>
-            </a:r>
-          </a:p>
-        </p:txBody>
-      </p:sp>
-    </p:spTree>
-  </p:cSld>
-  <p:clrMapOvr>
-    <a:masterClrMapping/>
-  </p:clrMapOvr>
-</p:sld>
-</file>
-
-<file path=ppt/slides/slide5.xml><?xml version="1.0" encoding="utf-8"?>
-<p:sld xmlns:a="http://schemas.openxmlformats.org/drawingml/2006/main" xmlns:r="http://schemas.openxmlformats.org/officeDocument/2006/relationships" xmlns:p="http://schemas.openxmlformats.org/presentationml/2006/main">
-  <p:cSld>
-    <p:spTree>
-      <p:nvGrpSpPr>
-        <p:cNvPr id="1" name=""/>
-        <p:cNvGrpSpPr/>
-        <p:nvPr/>
-      </p:nvGrpSpPr>
-      <p:grpSpPr>
-        <a:xfrm>
-          <a:off x="0" y="0"/>
-          <a:ext cx="0" cy="0"/>
-          <a:chOff x="0" y="0"/>
-          <a:chExt cx="0" cy="0"/>
-        </a:xfrm>
-      </p:grpSpPr>
-      <p:sp>
-        <p:nvSpPr>
-          <p:cNvPr id="2" name="TextBox 1"/>
-          <p:cNvSpPr txBox="1"/>
-          <p:nvPr/>
-        </p:nvSpPr>
-        <p:spPr>
-          <a:xfrm>
-            <a:off x="0" y="635505"/>
-            <a:ext cx="12192000" cy="5469203"/>
-          </a:xfrm>
-          <a:prstGeom prst="rect">
-            <a:avLst/>
-          </a:prstGeom>
-          <a:noFill/>
-        </p:spPr>
-        <p:txBody>
-          <a:bodyPr wrap="square">
-            <a:noAutofit/>
-          </a:bodyPr>
-          <a:lstStyle/>
-          <a:p>
-            <a:pPr marL="0" marR="0" lvl="0" indent="0" algn="ctr" defTabSz="914400" rtl="0" eaLnBrk="1" fontAlgn="auto" latinLnBrk="1" hangingPunct="1">
-              <a:lnSpc>
-                <a:spcPct val="100000"/>
-              </a:lnSpc>
-              <a:spcBef>
-                <a:spcPts val="0"/>
-              </a:spcBef>
-              <a:spcAft>
-                <a:spcPts val="0"/>
-              </a:spcAft>
-              <a:buClrTx/>
-              <a:buSzTx/>
-              <a:buFontTx/>
-              <a:buNone/>
-              <a:tabLst/>
-              <a:defRPr/>
-            </a:pPr>
-            <a:r>
-              <a:rPr lang="ko-KR" altLang="en-US" sz="7200" b="1" spc="-300" dirty="0">
-                <a:ln w="9525">
-                  <a:solidFill>
-                    <a:prstClr val="black"/>
-                  </a:solidFill>
-                </a:ln>
-                <a:solidFill>
-                  <a:srgbClr val="FFFFFF"/>
-                </a:solidFill>
-                <a:latin typeface="휴먼모음T" panose="02030504000101010101" pitchFamily="18" charset="-127"/>
-                <a:ea typeface="휴먼모음T" panose="02030504000101010101" pitchFamily="18" charset="-127"/>
-              </a:rPr>
-              <a:t>주님 사랑해요 </a:t>
-            </a:r>
-          </a:p>
-          <a:p>
-            <a:pPr marL="0" marR="0" lvl="0" indent="0" algn="ctr" defTabSz="914400" rtl="0" eaLnBrk="1" fontAlgn="auto" latinLnBrk="1" hangingPunct="1">
-              <a:lnSpc>
-                <a:spcPct val="100000"/>
-              </a:lnSpc>
-              <a:spcBef>
-                <a:spcPts val="0"/>
-              </a:spcBef>
-              <a:spcAft>
-                <a:spcPts val="0"/>
-              </a:spcAft>
-              <a:buClrTx/>
-              <a:buSzTx/>
-              <a:buFontTx/>
-              <a:buNone/>
-              <a:tabLst/>
-              <a:defRPr/>
-            </a:pPr>
-            <a:r>
-              <a:rPr lang="ko-KR" altLang="en-US" sz="7200" b="1" spc="-300" dirty="0">
-                <a:ln w="9525">
-                  <a:solidFill>
-                    <a:prstClr val="black"/>
-                  </a:solidFill>
-                </a:ln>
-                <a:solidFill>
-                  <a:srgbClr val="FFFFFF"/>
-                </a:solidFill>
-                <a:latin typeface="휴먼모음T" panose="02030504000101010101" pitchFamily="18" charset="-127"/>
-                <a:ea typeface="휴먼모음T" panose="02030504000101010101" pitchFamily="18" charset="-127"/>
-              </a:rPr>
-              <a:t>온 맘과 정성 다해</a:t>
-            </a:r>
-          </a:p>
-          <a:p>
-            <a:pPr marL="0" marR="0" lvl="0" indent="0" algn="ctr" defTabSz="914400" rtl="0" eaLnBrk="1" fontAlgn="auto" latinLnBrk="1" hangingPunct="1">
-              <a:lnSpc>
-                <a:spcPct val="100000"/>
-              </a:lnSpc>
-              <a:spcBef>
-                <a:spcPts val="0"/>
-              </a:spcBef>
-              <a:spcAft>
-                <a:spcPts val="0"/>
-              </a:spcAft>
-              <a:buClrTx/>
-              <a:buSzTx/>
-              <a:buFontTx/>
-              <a:buNone/>
-              <a:tabLst/>
-              <a:defRPr/>
-            </a:pPr>
-            <a:r>
-              <a:rPr lang="ko-KR" altLang="en-US" sz="7200" b="1" spc="-300" dirty="0">
-                <a:ln w="9525">
-                  <a:solidFill>
-                    <a:prstClr val="black"/>
-                  </a:solidFill>
-                </a:ln>
-                <a:solidFill>
-                  <a:srgbClr val="FFFFFF"/>
-                </a:solidFill>
-                <a:latin typeface="휴먼모음T" panose="02030504000101010101" pitchFamily="18" charset="-127"/>
-                <a:ea typeface="휴먼모음T" panose="02030504000101010101" pitchFamily="18" charset="-127"/>
-              </a:rPr>
-              <a:t>하나님의 신실한</a:t>
-            </a:r>
-          </a:p>
-          <a:p>
-            <a:pPr marL="0" marR="0" lvl="0" indent="0" algn="ctr" defTabSz="914400" rtl="0" eaLnBrk="1" fontAlgn="auto" latinLnBrk="1" hangingPunct="1">
-              <a:lnSpc>
-                <a:spcPct val="100000"/>
-              </a:lnSpc>
-              <a:spcBef>
-                <a:spcPts val="0"/>
-              </a:spcBef>
-              <a:spcAft>
-                <a:spcPts val="0"/>
-              </a:spcAft>
-              <a:buClrTx/>
-              <a:buSzTx/>
-              <a:buFontTx/>
-              <a:buNone/>
-              <a:tabLst/>
-              <a:defRPr/>
-            </a:pPr>
-            <a:r>
-              <a:rPr lang="ko-KR" altLang="en-US" sz="7200" b="1" spc="-300" dirty="0">
-                <a:ln w="9525">
-                  <a:solidFill>
-                    <a:prstClr val="black"/>
-                  </a:solidFill>
-                </a:ln>
-                <a:solidFill>
-                  <a:srgbClr val="FFFFFF"/>
-                </a:solidFill>
-                <a:latin typeface="휴먼모음T" panose="02030504000101010101" pitchFamily="18" charset="-127"/>
-                <a:ea typeface="휴먼모음T" panose="02030504000101010101" pitchFamily="18" charset="-127"/>
-              </a:rPr>
-              <a:t>친구 되기 원합니다 X2-3</a:t>
+              <a:t>친구 되기 원합니다</a:t>
             </a:r>
           </a:p>
         </p:txBody>

</xml_diff>